<commit_message>
Product- Creating necessary files
</commit_message>
<xml_diff>
--- a/.lessons/59 Vendor Product And Related Features/1 Vendor Profile- working with vendor profile (part - 1)/1.pptx
+++ b/.lessons/59 Vendor Product And Related Features/1 Vendor Profile- working with vendor profile (part - 1)/1.pptx
@@ -4103,7 +4103,7 @@
               <a:rPr lang="az-Latn-AZ" altLang="en-US" sz="1300">
                 <a:latin typeface="Arial" panose="020B0604020202020204" pitchFamily="34" charset="0"/>
               </a:rPr>
-              <a:t>Yeni bir VENDOR əlavə etmək üçün Seeder yaradırıq. Sonra seeder -I işə salırıq və yeni satıcı verilənlər bazasında yaradılır. Növbəti slayd...</a:t>
+              <a:t>Yeni bir VENDOR əlavə etmək üçün Seeder yaradırıq. Sonra seeder -ı işə salırıq və yeni satıcı verilənlər bazasında yaradılır. Növbəti slayd...</a:t>
             </a:r>
             <a:endParaRPr kumimoji="0" lang="en-US" altLang="en-US" sz="1300" b="0" i="0" u="none" strike="noStrike" cap="none" normalizeH="0" baseline="0">
               <a:ln>
@@ -4222,7 +4222,7 @@
               <a:rPr lang="az-Latn-AZ" altLang="en-US" sz="1300">
                 <a:latin typeface="Arial" panose="020B0604020202020204" pitchFamily="34" charset="0"/>
               </a:rPr>
-              <a:t>Həmin əlavə edilən yeni satıcı.</a:t>
+              <a:t>Həmin əlavə edilən yeni satıcı profili.</a:t>
             </a:r>
             <a:endParaRPr kumimoji="0" lang="en-US" altLang="en-US" sz="1300" b="0" i="0" u="none" strike="noStrike" cap="none" normalizeH="0" baseline="0">
               <a:ln>
@@ -4371,7 +4371,7 @@
               <a:rPr lang="az-Latn-AZ" altLang="en-US" sz="1300">
                 <a:latin typeface="Arial" panose="020B0604020202020204" pitchFamily="34" charset="0"/>
               </a:rPr>
-              <a:t>VENDOR modelini controllerdə çağıraraq, satıcı məlumatlarını şablona göndəririk. </a:t>
+              <a:t>VENDOR modelini controllerdə çağıraraq, satıcı profilinin məlumatlarını şablona göndəririk. </a:t>
             </a:r>
             <a:endParaRPr kumimoji="0" lang="en-US" altLang="en-US" sz="1300" b="0" i="0" u="none" strike="noStrike" cap="none" normalizeH="0" baseline="0">
               <a:ln>

</xml_diff>

<commit_message>
Product Variant - Creating necessary files
</commit_message>
<xml_diff>
--- a/.lessons/59 Vendor Product And Related Features/1 Vendor Profile- working with vendor profile (part - 1)/1.pptx
+++ b/.lessons/59 Vendor Product And Related Features/1 Vendor Profile- working with vendor profile (part - 1)/1.pptx
@@ -5,24 +5,24 @@
     <p:sldMasterId id="2147483648" r:id="rId1"/>
   </p:sldMasterIdLst>
   <p:sldIdLst>
-    <p:sldId id="413" r:id="rId2"/>
-    <p:sldId id="414" r:id="rId3"/>
-    <p:sldId id="416" r:id="rId4"/>
-    <p:sldId id="417" r:id="rId5"/>
-    <p:sldId id="418" r:id="rId6"/>
-    <p:sldId id="419" r:id="rId7"/>
-    <p:sldId id="420" r:id="rId8"/>
-    <p:sldId id="421" r:id="rId9"/>
-    <p:sldId id="422" r:id="rId10"/>
-    <p:sldId id="423" r:id="rId11"/>
-    <p:sldId id="424" r:id="rId12"/>
-    <p:sldId id="425" r:id="rId13"/>
-    <p:sldId id="426" r:id="rId14"/>
-    <p:sldId id="427" r:id="rId15"/>
-    <p:sldId id="430" r:id="rId16"/>
-    <p:sldId id="431" r:id="rId17"/>
-    <p:sldId id="432" r:id="rId18"/>
-    <p:sldId id="429" r:id="rId19"/>
+    <p:sldId id="429" r:id="rId2"/>
+    <p:sldId id="413" r:id="rId3"/>
+    <p:sldId id="414" r:id="rId4"/>
+    <p:sldId id="416" r:id="rId5"/>
+    <p:sldId id="417" r:id="rId6"/>
+    <p:sldId id="418" r:id="rId7"/>
+    <p:sldId id="419" r:id="rId8"/>
+    <p:sldId id="420" r:id="rId9"/>
+    <p:sldId id="421" r:id="rId10"/>
+    <p:sldId id="422" r:id="rId11"/>
+    <p:sldId id="423" r:id="rId12"/>
+    <p:sldId id="424" r:id="rId13"/>
+    <p:sldId id="425" r:id="rId14"/>
+    <p:sldId id="426" r:id="rId15"/>
+    <p:sldId id="427" r:id="rId16"/>
+    <p:sldId id="430" r:id="rId17"/>
+    <p:sldId id="431" r:id="rId18"/>
+    <p:sldId id="432" r:id="rId19"/>
     <p:sldId id="415" r:id="rId20"/>
   </p:sldIdLst>
   <p:sldSz cx="12192000" cy="6858000"/>
@@ -277,7 +277,7 @@
           <a:p>
             <a:fld id="{3E102D2E-813C-461C-9963-687A650C48C0}" type="datetimeFigureOut">
               <a:rPr lang="en-US" smtClean="0"/>
-              <a:t>12/16/2025</a:t>
+              <a:t>12/22/2025</a:t>
             </a:fld>
             <a:endParaRPr lang="en-US"/>
           </a:p>
@@ -475,7 +475,7 @@
           <a:p>
             <a:fld id="{3E102D2E-813C-461C-9963-687A650C48C0}" type="datetimeFigureOut">
               <a:rPr lang="en-US" smtClean="0"/>
-              <a:t>12/16/2025</a:t>
+              <a:t>12/22/2025</a:t>
             </a:fld>
             <a:endParaRPr lang="en-US"/>
           </a:p>
@@ -683,7 +683,7 @@
           <a:p>
             <a:fld id="{3E102D2E-813C-461C-9963-687A650C48C0}" type="datetimeFigureOut">
               <a:rPr lang="en-US" smtClean="0"/>
-              <a:t>12/16/2025</a:t>
+              <a:t>12/22/2025</a:t>
             </a:fld>
             <a:endParaRPr lang="en-US"/>
           </a:p>
@@ -881,7 +881,7 @@
           <a:p>
             <a:fld id="{3E102D2E-813C-461C-9963-687A650C48C0}" type="datetimeFigureOut">
               <a:rPr lang="en-US" smtClean="0"/>
-              <a:t>12/16/2025</a:t>
+              <a:t>12/22/2025</a:t>
             </a:fld>
             <a:endParaRPr lang="en-US"/>
           </a:p>
@@ -1156,7 +1156,7 @@
           <a:p>
             <a:fld id="{3E102D2E-813C-461C-9963-687A650C48C0}" type="datetimeFigureOut">
               <a:rPr lang="en-US" smtClean="0"/>
-              <a:t>12/16/2025</a:t>
+              <a:t>12/22/2025</a:t>
             </a:fld>
             <a:endParaRPr lang="en-US"/>
           </a:p>
@@ -1421,7 +1421,7 @@
           <a:p>
             <a:fld id="{3E102D2E-813C-461C-9963-687A650C48C0}" type="datetimeFigureOut">
               <a:rPr lang="en-US" smtClean="0"/>
-              <a:t>12/16/2025</a:t>
+              <a:t>12/22/2025</a:t>
             </a:fld>
             <a:endParaRPr lang="en-US"/>
           </a:p>
@@ -1833,7 +1833,7 @@
           <a:p>
             <a:fld id="{3E102D2E-813C-461C-9963-687A650C48C0}" type="datetimeFigureOut">
               <a:rPr lang="en-US" smtClean="0"/>
-              <a:t>12/16/2025</a:t>
+              <a:t>12/22/2025</a:t>
             </a:fld>
             <a:endParaRPr lang="en-US"/>
           </a:p>
@@ -1974,7 +1974,7 @@
           <a:p>
             <a:fld id="{3E102D2E-813C-461C-9963-687A650C48C0}" type="datetimeFigureOut">
               <a:rPr lang="en-US" smtClean="0"/>
-              <a:t>12/16/2025</a:t>
+              <a:t>12/22/2025</a:t>
             </a:fld>
             <a:endParaRPr lang="en-US"/>
           </a:p>
@@ -2087,7 +2087,7 @@
           <a:p>
             <a:fld id="{3E102D2E-813C-461C-9963-687A650C48C0}" type="datetimeFigureOut">
               <a:rPr lang="en-US" smtClean="0"/>
-              <a:t>12/16/2025</a:t>
+              <a:t>12/22/2025</a:t>
             </a:fld>
             <a:endParaRPr lang="en-US"/>
           </a:p>
@@ -2398,7 +2398,7 @@
           <a:p>
             <a:fld id="{3E102D2E-813C-461C-9963-687A650C48C0}" type="datetimeFigureOut">
               <a:rPr lang="en-US" smtClean="0"/>
-              <a:t>12/16/2025</a:t>
+              <a:t>12/22/2025</a:t>
             </a:fld>
             <a:endParaRPr lang="en-US"/>
           </a:p>
@@ -2686,7 +2686,7 @@
           <a:p>
             <a:fld id="{3E102D2E-813C-461C-9963-687A650C48C0}" type="datetimeFigureOut">
               <a:rPr lang="en-US" smtClean="0"/>
-              <a:t>12/16/2025</a:t>
+              <a:t>12/22/2025</a:t>
             </a:fld>
             <a:endParaRPr lang="en-US"/>
           </a:p>
@@ -2927,7 +2927,7 @@
           <a:p>
             <a:fld id="{3E102D2E-813C-461C-9963-687A650C48C0}" type="datetimeFigureOut">
               <a:rPr lang="en-US" smtClean="0"/>
-              <a:t>12/16/2025</a:t>
+              <a:t>12/22/2025</a:t>
             </a:fld>
             <a:endParaRPr lang="en-US"/>
           </a:p>
@@ -3335,7 +3335,7 @@
         <p:cNvPr id="1" name="">
           <a:extLst>
             <a:ext uri="{FF2B5EF4-FFF2-40B4-BE49-F238E27FC236}">
-              <a16:creationId xmlns:a16="http://schemas.microsoft.com/office/drawing/2014/main" id="{6A435CBA-29A4-BFD2-CEA7-3290D85ED9F8}"/>
+              <a16:creationId xmlns:a16="http://schemas.microsoft.com/office/drawing/2014/main" id="{78B905EA-4A6E-B2E2-45E0-007643ECBC36}"/>
             </a:ext>
           </a:extLst>
         </p:cNvPr>
@@ -3355,7 +3355,7 @@
           <p:cNvPr id="3" name="TextBox 2">
             <a:extLst>
               <a:ext uri="{FF2B5EF4-FFF2-40B4-BE49-F238E27FC236}">
-                <a16:creationId xmlns:a16="http://schemas.microsoft.com/office/drawing/2014/main" id="{A727ABBC-76D0-B81B-760F-26FC272AF479}"/>
+                <a16:creationId xmlns:a16="http://schemas.microsoft.com/office/drawing/2014/main" id="{F764284E-9F0A-A80B-8150-5991076B90A6}"/>
               </a:ext>
             </a:extLst>
           </p:cNvPr>
@@ -3365,7 +3365,7 @@
         <p:spPr>
           <a:xfrm>
             <a:off x="0" y="0"/>
-            <a:ext cx="12192000" cy="355354"/>
+            <a:ext cx="12192000" cy="955518"/>
           </a:xfrm>
           <a:prstGeom prst="rect">
             <a:avLst/>
@@ -3385,22 +3385,70 @@
               <a:buNone/>
             </a:pPr>
             <a:r>
+              <a:rPr lang="en-US" altLang="en-US" sz="1300" b="1">
+                <a:highlight>
+                  <a:srgbClr val="FFFF00"/>
+                </a:highlight>
+                <a:latin typeface="Arial" panose="020B0604020202020204" pitchFamily="34" charset="0"/>
+              </a:rPr>
+              <a:t>NOT</a:t>
+            </a:r>
+            <a:r>
+              <a:rPr lang="en-US" altLang="en-US" sz="1300">
+                <a:latin typeface="Arial" panose="020B0604020202020204" pitchFamily="34" charset="0"/>
+              </a:rPr>
+              <a:t>: Kodlar</a:t>
+            </a:r>
+            <a:r>
               <a:rPr lang="az-Latn-AZ" altLang="en-US" sz="1300">
                 <a:latin typeface="Arial" panose="020B0604020202020204" pitchFamily="34" charset="0"/>
               </a:rPr>
-              <a:t>İndi saytda </a:t>
-            </a:r>
-            <a:r>
-              <a:rPr lang="az-Latn-AZ" altLang="en-US" sz="1300" b="1">
+              <a:t>ı 59-9 nömrəli qovluqdan götürün. </a:t>
+            </a:r>
+          </a:p>
+          <a:p>
+            <a:pPr>
+              <a:lnSpc>
+                <a:spcPct val="150000"/>
+              </a:lnSpc>
+              <a:buNone/>
+            </a:pPr>
+            <a:endParaRPr kumimoji="0" lang="az-Latn-AZ" altLang="en-US" sz="1300" b="0" i="0" u="none" strike="noStrike" cap="none" normalizeH="0" baseline="0">
+              <a:ln>
+                <a:noFill/>
+              </a:ln>
+              <a:solidFill>
+                <a:schemeClr val="tx1"/>
+              </a:solidFill>
+              <a:effectLst/>
+              <a:latin typeface="Arial" panose="020B0604020202020204" pitchFamily="34" charset="0"/>
+            </a:endParaRPr>
+          </a:p>
+          <a:p>
+            <a:pPr>
+              <a:lnSpc>
+                <a:spcPct val="150000"/>
+              </a:lnSpc>
+              <a:buNone/>
+            </a:pPr>
+            <a:r>
+              <a:rPr kumimoji="0" lang="az-Latn-AZ" altLang="en-US" sz="1300" b="0" i="0" u="none" strike="noStrike" cap="none" normalizeH="0" baseline="0">
+                <a:ln>
+                  <a:noFill/>
+                </a:ln>
+                <a:solidFill>
+                  <a:schemeClr val="tx1"/>
+                </a:solidFill>
+                <a:effectLst/>
                 <a:latin typeface="Arial" panose="020B0604020202020204" pitchFamily="34" charset="0"/>
               </a:rPr>
-              <a:t>VENDOR</a:t>
+              <a:t>Həmin qovluğa qədər edilən dəyişikliklər</a:t>
             </a:r>
             <a:r>
               <a:rPr lang="az-Latn-AZ" altLang="en-US" sz="1300">
                 <a:latin typeface="Arial" panose="020B0604020202020204" pitchFamily="34" charset="0"/>
               </a:rPr>
-              <a:t> olaraq daxil olaq. Şifrə 11111111 -dir.</a:t>
+              <a:t>in olduğu kodlar 1,2,3,4,5,6,7 və 8 nömrəli qovluqlarda olmuyacaq. </a:t>
             </a:r>
             <a:endParaRPr kumimoji="0" lang="en-US" altLang="en-US" sz="1300" b="0" i="0" u="none" strike="noStrike" cap="none" normalizeH="0" baseline="0">
               <a:ln>
@@ -3415,12 +3463,131 @@
           </a:p>
         </p:txBody>
       </p:sp>
+    </p:spTree>
+    <p:extLst>
+      <p:ext uri="{BB962C8B-B14F-4D97-AF65-F5344CB8AC3E}">
+        <p14:creationId xmlns:p14="http://schemas.microsoft.com/office/powerpoint/2010/main" val="2604949331"/>
+      </p:ext>
+    </p:extLst>
+  </p:cSld>
+  <p:clrMapOvr>
+    <a:masterClrMapping/>
+  </p:clrMapOvr>
+</p:sld>
+</file>
+
+<file path=ppt/slides/slide10.xml><?xml version="1.0" encoding="utf-8"?>
+<p:sld xmlns:a="http://schemas.openxmlformats.org/drawingml/2006/main" xmlns:r="http://schemas.openxmlformats.org/officeDocument/2006/relationships" xmlns:p="http://schemas.openxmlformats.org/presentationml/2006/main">
+  <p:cSld>
+    <p:spTree>
+      <p:nvGrpSpPr>
+        <p:cNvPr id="1" name="">
+          <a:extLst>
+            <a:ext uri="{FF2B5EF4-FFF2-40B4-BE49-F238E27FC236}">
+              <a16:creationId xmlns:a16="http://schemas.microsoft.com/office/drawing/2014/main" id="{C9993877-C99C-9C5C-B92A-B6775E82B086}"/>
+            </a:ext>
+          </a:extLst>
+        </p:cNvPr>
+        <p:cNvGrpSpPr/>
+        <p:nvPr/>
+      </p:nvGrpSpPr>
+      <p:grpSpPr>
+        <a:xfrm>
+          <a:off x="0" y="0"/>
+          <a:ext cx="0" cy="0"/>
+          <a:chOff x="0" y="0"/>
+          <a:chExt cx="0" cy="0"/>
+        </a:xfrm>
+      </p:grpSpPr>
+      <p:sp>
+        <p:nvSpPr>
+          <p:cNvPr id="3" name="TextBox 2">
+            <a:extLst>
+              <a:ext uri="{FF2B5EF4-FFF2-40B4-BE49-F238E27FC236}">
+                <a16:creationId xmlns:a16="http://schemas.microsoft.com/office/drawing/2014/main" id="{66975D2F-2CDE-113B-A76A-B325FE701F97}"/>
+              </a:ext>
+            </a:extLst>
+          </p:cNvPr>
+          <p:cNvSpPr txBox="1"/>
+          <p:nvPr/>
+        </p:nvSpPr>
+        <p:spPr>
+          <a:xfrm>
+            <a:off x="0" y="0"/>
+            <a:ext cx="12192000" cy="335156"/>
+          </a:xfrm>
+          <a:prstGeom prst="rect">
+            <a:avLst/>
+          </a:prstGeom>
+          <a:noFill/>
+        </p:spPr>
+        <p:txBody>
+          <a:bodyPr wrap="square">
+            <a:spAutoFit/>
+          </a:bodyPr>
+          <a:lstStyle/>
+          <a:p>
+            <a:pPr>
+              <a:lnSpc>
+                <a:spcPct val="150000"/>
+              </a:lnSpc>
+              <a:buNone/>
+            </a:pPr>
+            <a:r>
+              <a:rPr lang="en-US" altLang="en-US" sz="1200" b="1">
+                <a:latin typeface="Arial" panose="020B0604020202020204" pitchFamily="34" charset="0"/>
+              </a:rPr>
+              <a:t>resources\views\vendor\dashboard\dashboard.blade.php</a:t>
+            </a:r>
+            <a:r>
+              <a:rPr lang="az-Latn-AZ" altLang="en-US" sz="1200" b="1">
+                <a:latin typeface="Arial" panose="020B0604020202020204" pitchFamily="34" charset="0"/>
+              </a:rPr>
+              <a:t> </a:t>
+            </a:r>
+            <a:r>
+              <a:rPr lang="az-Latn-AZ" altLang="en-US" sz="1200">
+                <a:latin typeface="Arial" panose="020B0604020202020204" pitchFamily="34" charset="0"/>
+              </a:rPr>
+              <a:t>və </a:t>
+            </a:r>
+            <a:r>
+              <a:rPr lang="en-US" altLang="en-US" sz="1200" b="1">
+                <a:latin typeface="Arial" panose="020B0604020202020204" pitchFamily="34" charset="0"/>
+              </a:rPr>
+              <a:t>resources\views\vendor\dashboard\profile.blade.php</a:t>
+            </a:r>
+            <a:r>
+              <a:rPr lang="az-Latn-AZ" altLang="en-US" sz="1200" b="1">
+                <a:latin typeface="Arial" panose="020B0604020202020204" pitchFamily="34" charset="0"/>
+              </a:rPr>
+              <a:t> </a:t>
+            </a:r>
+            <a:r>
+              <a:rPr lang="az-Latn-AZ" altLang="en-US" sz="1200">
+                <a:latin typeface="Arial" panose="020B0604020202020204" pitchFamily="34" charset="0"/>
+              </a:rPr>
+              <a:t>faylındakı yolları düzəldirik.</a:t>
+            </a:r>
+            <a:endParaRPr kumimoji="0" lang="en-US" altLang="en-US" sz="1200" b="0" i="0" u="none" strike="noStrike" cap="none" normalizeH="0" baseline="0">
+              <a:ln>
+                <a:noFill/>
+              </a:ln>
+              <a:solidFill>
+                <a:schemeClr val="tx1"/>
+              </a:solidFill>
+              <a:effectLst/>
+              <a:latin typeface="Arial" panose="020B0604020202020204" pitchFamily="34" charset="0"/>
+            </a:endParaRPr>
+          </a:p>
+        </p:txBody>
+      </p:sp>
       <p:pic>
         <p:nvPicPr>
-          <p:cNvPr id="4" name="Picture 3" descr="A screenshot of a computer&#10;&#10;AI-generated content may be incorrect.">
-            <a:extLst>
-              <a:ext uri="{FF2B5EF4-FFF2-40B4-BE49-F238E27FC236}">
-                <a16:creationId xmlns:a16="http://schemas.microsoft.com/office/drawing/2014/main" id="{9386D3CC-F8AC-9712-EBFD-32CA62D8E393}"/>
+          <p:cNvPr id="4" name="Picture 3" descr="A screenshot of a computer program&#10;&#10;AI-generated content may be incorrect.">
+            <a:extLst>
+              <a:ext uri="{FF2B5EF4-FFF2-40B4-BE49-F238E27FC236}">
+                <a16:creationId xmlns:a16="http://schemas.microsoft.com/office/drawing/2014/main" id="{C209D8C4-EDC0-C271-4F83-3E1A830A5174}"/>
               </a:ext>
             </a:extLst>
           </p:cNvPr>
@@ -3437,8 +3604,114 @@
         </p:blipFill>
         <p:spPr>
           <a:xfrm>
-            <a:off x="1514764" y="625678"/>
-            <a:ext cx="10677236" cy="6232322"/>
+            <a:off x="0" y="657923"/>
+            <a:ext cx="8020900" cy="2771078"/>
+          </a:xfrm>
+          <a:prstGeom prst="rect">
+            <a:avLst/>
+          </a:prstGeom>
+        </p:spPr>
+      </p:pic>
+      <p:pic>
+        <p:nvPicPr>
+          <p:cNvPr id="6" name="Picture 5" descr="A screenshot of a computer program&#10;&#10;AI-generated content may be incorrect.">
+            <a:extLst>
+              <a:ext uri="{FF2B5EF4-FFF2-40B4-BE49-F238E27FC236}">
+                <a16:creationId xmlns:a16="http://schemas.microsoft.com/office/drawing/2014/main" id="{2FC6F0B9-AC2E-1AC9-931E-4B1E73D8492B}"/>
+              </a:ext>
+            </a:extLst>
+          </p:cNvPr>
+          <p:cNvPicPr>
+            <a:picLocks noChangeAspect="1"/>
+          </p:cNvPicPr>
+          <p:nvPr/>
+        </p:nvPicPr>
+        <p:blipFill>
+          <a:blip r:embed="rId3"/>
+          <a:stretch>
+            <a:fillRect/>
+          </a:stretch>
+        </p:blipFill>
+        <p:spPr>
+          <a:xfrm>
+            <a:off x="0" y="3910304"/>
+            <a:ext cx="7989455" cy="2947696"/>
+          </a:xfrm>
+          <a:prstGeom prst="rect">
+            <a:avLst/>
+          </a:prstGeom>
+        </p:spPr>
+      </p:pic>
+      <p:sp>
+        <p:nvSpPr>
+          <p:cNvPr id="7" name="Arrow: Down 6">
+            <a:extLst>
+              <a:ext uri="{FF2B5EF4-FFF2-40B4-BE49-F238E27FC236}">
+                <a16:creationId xmlns:a16="http://schemas.microsoft.com/office/drawing/2014/main" id="{7D9A9959-AB55-4EDC-5FA1-B3F2EE056C06}"/>
+              </a:ext>
+            </a:extLst>
+          </p:cNvPr>
+          <p:cNvSpPr/>
+          <p:nvPr/>
+        </p:nvSpPr>
+        <p:spPr>
+          <a:xfrm>
+            <a:off x="3765686" y="3540343"/>
+            <a:ext cx="277091" cy="258618"/>
+          </a:xfrm>
+          <a:prstGeom prst="downArrow">
+            <a:avLst/>
+          </a:prstGeom>
+        </p:spPr>
+        <p:style>
+          <a:lnRef idx="2">
+            <a:schemeClr val="dk1">
+              <a:shade val="15000"/>
+            </a:schemeClr>
+          </a:lnRef>
+          <a:fillRef idx="1">
+            <a:schemeClr val="dk1"/>
+          </a:fillRef>
+          <a:effectRef idx="0">
+            <a:schemeClr val="dk1"/>
+          </a:effectRef>
+          <a:fontRef idx="minor">
+            <a:schemeClr val="lt1"/>
+          </a:fontRef>
+        </p:style>
+        <p:txBody>
+          <a:bodyPr rtlCol="0" anchor="ctr"/>
+          <a:lstStyle/>
+          <a:p>
+            <a:pPr algn="ctr"/>
+            <a:endParaRPr lang="en-US"/>
+          </a:p>
+        </p:txBody>
+      </p:sp>
+      <p:pic>
+        <p:nvPicPr>
+          <p:cNvPr id="9" name="Picture 8" descr="A screenshot of a computer&#10;&#10;AI-generated content may be incorrect.">
+            <a:extLst>
+              <a:ext uri="{FF2B5EF4-FFF2-40B4-BE49-F238E27FC236}">
+                <a16:creationId xmlns:a16="http://schemas.microsoft.com/office/drawing/2014/main" id="{270BD822-6123-409A-D2B5-0C82A3FE6CE8}"/>
+              </a:ext>
+            </a:extLst>
+          </p:cNvPr>
+          <p:cNvPicPr>
+            <a:picLocks noChangeAspect="1"/>
+          </p:cNvPicPr>
+          <p:nvPr/>
+        </p:nvPicPr>
+        <p:blipFill>
+          <a:blip r:embed="rId4"/>
+          <a:stretch>
+            <a:fillRect/>
+          </a:stretch>
+        </p:blipFill>
+        <p:spPr>
+          <a:xfrm>
+            <a:off x="9663717" y="657923"/>
+            <a:ext cx="2528283" cy="1226960"/>
           </a:xfrm>
           <a:prstGeom prst="rect">
             <a:avLst/>
@@ -3448,7 +3721,7 @@
     </p:spTree>
     <p:extLst>
       <p:ext uri="{BB962C8B-B14F-4D97-AF65-F5344CB8AC3E}">
-        <p14:creationId xmlns:p14="http://schemas.microsoft.com/office/powerpoint/2010/main" val="3863838039"/>
+        <p14:creationId xmlns:p14="http://schemas.microsoft.com/office/powerpoint/2010/main" val="1663773691"/>
       </p:ext>
     </p:extLst>
   </p:cSld>
@@ -3458,7 +3731,7 @@
 </p:sld>
 </file>
 
-<file path=ppt/slides/slide10.xml><?xml version="1.0" encoding="utf-8"?>
+<file path=ppt/slides/slide11.xml><?xml version="1.0" encoding="utf-8"?>
 <p:sld xmlns:a="http://schemas.openxmlformats.org/drawingml/2006/main" xmlns:r="http://schemas.openxmlformats.org/officeDocument/2006/relationships" xmlns:p="http://schemas.openxmlformats.org/presentationml/2006/main">
   <p:cSld>
     <p:spTree>
@@ -3577,7 +3850,7 @@
 </p:sld>
 </file>
 
-<file path=ppt/slides/slide11.xml><?xml version="1.0" encoding="utf-8"?>
+<file path=ppt/slides/slide12.xml><?xml version="1.0" encoding="utf-8"?>
 <p:sld xmlns:a="http://schemas.openxmlformats.org/drawingml/2006/main" xmlns:r="http://schemas.openxmlformats.org/officeDocument/2006/relationships" xmlns:p="http://schemas.openxmlformats.org/presentationml/2006/main">
   <p:cSld>
     <p:spTree>
@@ -3702,7 +3975,7 @@
 </p:sld>
 </file>
 
-<file path=ppt/slides/slide12.xml><?xml version="1.0" encoding="utf-8"?>
+<file path=ppt/slides/slide13.xml><?xml version="1.0" encoding="utf-8"?>
 <p:sld xmlns:a="http://schemas.openxmlformats.org/drawingml/2006/main" xmlns:r="http://schemas.openxmlformats.org/officeDocument/2006/relationships" xmlns:p="http://schemas.openxmlformats.org/presentationml/2006/main">
   <p:cSld>
     <p:spTree>
@@ -3818,7 +4091,7 @@
 </p:sld>
 </file>
 
-<file path=ppt/slides/slide13.xml><?xml version="1.0" encoding="utf-8"?>
+<file path=ppt/slides/slide14.xml><?xml version="1.0" encoding="utf-8"?>
 <p:sld xmlns:a="http://schemas.openxmlformats.org/drawingml/2006/main" xmlns:r="http://schemas.openxmlformats.org/officeDocument/2006/relationships" xmlns:p="http://schemas.openxmlformats.org/presentationml/2006/main">
   <p:cSld>
     <p:spTree>
@@ -4042,7 +4315,7 @@
 </p:sld>
 </file>
 
-<file path=ppt/slides/slide14.xml><?xml version="1.0" encoding="utf-8"?>
+<file path=ppt/slides/slide15.xml><?xml version="1.0" encoding="utf-8"?>
 <p:sld xmlns:a="http://schemas.openxmlformats.org/drawingml/2006/main" xmlns:r="http://schemas.openxmlformats.org/officeDocument/2006/relationships" xmlns:p="http://schemas.openxmlformats.org/presentationml/2006/main">
   <p:cSld>
     <p:spTree>
@@ -4161,7 +4434,7 @@
 </p:sld>
 </file>
 
-<file path=ppt/slides/slide15.xml><?xml version="1.0" encoding="utf-8"?>
+<file path=ppt/slides/slide16.xml><?xml version="1.0" encoding="utf-8"?>
 <p:sld xmlns:a="http://schemas.openxmlformats.org/drawingml/2006/main" xmlns:r="http://schemas.openxmlformats.org/officeDocument/2006/relationships" xmlns:p="http://schemas.openxmlformats.org/presentationml/2006/main">
   <p:cSld>
     <p:spTree>
@@ -4310,7 +4583,7 @@
 </p:sld>
 </file>
 
-<file path=ppt/slides/slide16.xml><?xml version="1.0" encoding="utf-8"?>
+<file path=ppt/slides/slide17.xml><?xml version="1.0" encoding="utf-8"?>
 <p:sld xmlns:a="http://schemas.openxmlformats.org/drawingml/2006/main" xmlns:r="http://schemas.openxmlformats.org/officeDocument/2006/relationships" xmlns:p="http://schemas.openxmlformats.org/presentationml/2006/main">
   <p:cSld>
     <p:spTree>
@@ -4429,7 +4702,7 @@
 </p:sld>
 </file>
 
-<file path=ppt/slides/slide17.xml><?xml version="1.0" encoding="utf-8"?>
+<file path=ppt/slides/slide18.xml><?xml version="1.0" encoding="utf-8"?>
 <p:sld xmlns:a="http://schemas.openxmlformats.org/drawingml/2006/main" xmlns:r="http://schemas.openxmlformats.org/officeDocument/2006/relationships" xmlns:p="http://schemas.openxmlformats.org/presentationml/2006/main">
   <p:cSld>
     <p:spTree>
@@ -4570,92 +4843,6 @@
     <p:extLst>
       <p:ext uri="{BB962C8B-B14F-4D97-AF65-F5344CB8AC3E}">
         <p14:creationId xmlns:p14="http://schemas.microsoft.com/office/powerpoint/2010/main" val="555851528"/>
-      </p:ext>
-    </p:extLst>
-  </p:cSld>
-  <p:clrMapOvr>
-    <a:masterClrMapping/>
-  </p:clrMapOvr>
-</p:sld>
-</file>
-
-<file path=ppt/slides/slide18.xml><?xml version="1.0" encoding="utf-8"?>
-<p:sld xmlns:a="http://schemas.openxmlformats.org/drawingml/2006/main" xmlns:r="http://schemas.openxmlformats.org/officeDocument/2006/relationships" xmlns:p="http://schemas.openxmlformats.org/presentationml/2006/main">
-  <p:cSld>
-    <p:spTree>
-      <p:nvGrpSpPr>
-        <p:cNvPr id="1" name="">
-          <a:extLst>
-            <a:ext uri="{FF2B5EF4-FFF2-40B4-BE49-F238E27FC236}">
-              <a16:creationId xmlns:a16="http://schemas.microsoft.com/office/drawing/2014/main" id="{78B905EA-4A6E-B2E2-45E0-007643ECBC36}"/>
-            </a:ext>
-          </a:extLst>
-        </p:cNvPr>
-        <p:cNvGrpSpPr/>
-        <p:nvPr/>
-      </p:nvGrpSpPr>
-      <p:grpSpPr>
-        <a:xfrm>
-          <a:off x="0" y="0"/>
-          <a:ext cx="0" cy="0"/>
-          <a:chOff x="0" y="0"/>
-          <a:chExt cx="0" cy="0"/>
-        </a:xfrm>
-      </p:grpSpPr>
-      <p:sp>
-        <p:nvSpPr>
-          <p:cNvPr id="3" name="TextBox 2">
-            <a:extLst>
-              <a:ext uri="{FF2B5EF4-FFF2-40B4-BE49-F238E27FC236}">
-                <a16:creationId xmlns:a16="http://schemas.microsoft.com/office/drawing/2014/main" id="{F764284E-9F0A-A80B-8150-5991076B90A6}"/>
-              </a:ext>
-            </a:extLst>
-          </p:cNvPr>
-          <p:cNvSpPr txBox="1"/>
-          <p:nvPr/>
-        </p:nvSpPr>
-        <p:spPr>
-          <a:xfrm>
-            <a:off x="0" y="0"/>
-            <a:ext cx="12192000" cy="355354"/>
-          </a:xfrm>
-          <a:prstGeom prst="rect">
-            <a:avLst/>
-          </a:prstGeom>
-          <a:noFill/>
-        </p:spPr>
-        <p:txBody>
-          <a:bodyPr wrap="square">
-            <a:spAutoFit/>
-          </a:bodyPr>
-          <a:lstStyle/>
-          <a:p>
-            <a:pPr>
-              <a:lnSpc>
-                <a:spcPct val="150000"/>
-              </a:lnSpc>
-              <a:buNone/>
-            </a:pPr>
-            <a:r>
-              <a:rPr kumimoji="0" lang="en-US" altLang="en-US" sz="1300" b="0" i="0" u="none" strike="noStrike" cap="none" normalizeH="0" baseline="0">
-                <a:ln>
-                  <a:noFill/>
-                </a:ln>
-                <a:solidFill>
-                  <a:schemeClr val="tx1"/>
-                </a:solidFill>
-                <a:effectLst/>
-                <a:latin typeface="Arial" panose="020B0604020202020204" pitchFamily="34" charset="0"/>
-              </a:rPr>
-              <a:t>.</a:t>
-            </a:r>
-          </a:p>
-        </p:txBody>
-      </p:sp>
-    </p:spTree>
-    <p:extLst>
-      <p:ext uri="{BB962C8B-B14F-4D97-AF65-F5344CB8AC3E}">
-        <p14:creationId xmlns:p14="http://schemas.microsoft.com/office/powerpoint/2010/main" val="2604949331"/>
       </p:ext>
     </p:extLst>
   </p:cSld>
@@ -4759,6 +4946,137 @@
         <p:cNvPr id="1" name="">
           <a:extLst>
             <a:ext uri="{FF2B5EF4-FFF2-40B4-BE49-F238E27FC236}">
+              <a16:creationId xmlns:a16="http://schemas.microsoft.com/office/drawing/2014/main" id="{6A435CBA-29A4-BFD2-CEA7-3290D85ED9F8}"/>
+            </a:ext>
+          </a:extLst>
+        </p:cNvPr>
+        <p:cNvGrpSpPr/>
+        <p:nvPr/>
+      </p:nvGrpSpPr>
+      <p:grpSpPr>
+        <a:xfrm>
+          <a:off x="0" y="0"/>
+          <a:ext cx="0" cy="0"/>
+          <a:chOff x="0" y="0"/>
+          <a:chExt cx="0" cy="0"/>
+        </a:xfrm>
+      </p:grpSpPr>
+      <p:sp>
+        <p:nvSpPr>
+          <p:cNvPr id="3" name="TextBox 2">
+            <a:extLst>
+              <a:ext uri="{FF2B5EF4-FFF2-40B4-BE49-F238E27FC236}">
+                <a16:creationId xmlns:a16="http://schemas.microsoft.com/office/drawing/2014/main" id="{A727ABBC-76D0-B81B-760F-26FC272AF479}"/>
+              </a:ext>
+            </a:extLst>
+          </p:cNvPr>
+          <p:cNvSpPr txBox="1"/>
+          <p:nvPr/>
+        </p:nvSpPr>
+        <p:spPr>
+          <a:xfrm>
+            <a:off x="0" y="0"/>
+            <a:ext cx="12192000" cy="355354"/>
+          </a:xfrm>
+          <a:prstGeom prst="rect">
+            <a:avLst/>
+          </a:prstGeom>
+          <a:noFill/>
+        </p:spPr>
+        <p:txBody>
+          <a:bodyPr wrap="square">
+            <a:spAutoFit/>
+          </a:bodyPr>
+          <a:lstStyle/>
+          <a:p>
+            <a:pPr>
+              <a:lnSpc>
+                <a:spcPct val="150000"/>
+              </a:lnSpc>
+              <a:buNone/>
+            </a:pPr>
+            <a:r>
+              <a:rPr lang="az-Latn-AZ" altLang="en-US" sz="1300">
+                <a:latin typeface="Arial" panose="020B0604020202020204" pitchFamily="34" charset="0"/>
+              </a:rPr>
+              <a:t>İndi saytda </a:t>
+            </a:r>
+            <a:r>
+              <a:rPr lang="az-Latn-AZ" altLang="en-US" sz="1300" b="1">
+                <a:latin typeface="Arial" panose="020B0604020202020204" pitchFamily="34" charset="0"/>
+              </a:rPr>
+              <a:t>VENDOR</a:t>
+            </a:r>
+            <a:r>
+              <a:rPr lang="az-Latn-AZ" altLang="en-US" sz="1300">
+                <a:latin typeface="Arial" panose="020B0604020202020204" pitchFamily="34" charset="0"/>
+              </a:rPr>
+              <a:t> olaraq daxil olaq. Şifrə 11111111 -dir.</a:t>
+            </a:r>
+            <a:endParaRPr kumimoji="0" lang="en-US" altLang="en-US" sz="1300" b="0" i="0" u="none" strike="noStrike" cap="none" normalizeH="0" baseline="0">
+              <a:ln>
+                <a:noFill/>
+              </a:ln>
+              <a:solidFill>
+                <a:schemeClr val="tx1"/>
+              </a:solidFill>
+              <a:effectLst/>
+              <a:latin typeface="Arial" panose="020B0604020202020204" pitchFamily="34" charset="0"/>
+            </a:endParaRPr>
+          </a:p>
+        </p:txBody>
+      </p:sp>
+      <p:pic>
+        <p:nvPicPr>
+          <p:cNvPr id="4" name="Picture 3" descr="A screenshot of a computer&#10;&#10;AI-generated content may be incorrect.">
+            <a:extLst>
+              <a:ext uri="{FF2B5EF4-FFF2-40B4-BE49-F238E27FC236}">
+                <a16:creationId xmlns:a16="http://schemas.microsoft.com/office/drawing/2014/main" id="{9386D3CC-F8AC-9712-EBFD-32CA62D8E393}"/>
+              </a:ext>
+            </a:extLst>
+          </p:cNvPr>
+          <p:cNvPicPr>
+            <a:picLocks noChangeAspect="1"/>
+          </p:cNvPicPr>
+          <p:nvPr/>
+        </p:nvPicPr>
+        <p:blipFill>
+          <a:blip r:embed="rId2"/>
+          <a:stretch>
+            <a:fillRect/>
+          </a:stretch>
+        </p:blipFill>
+        <p:spPr>
+          <a:xfrm>
+            <a:off x="1514764" y="625678"/>
+            <a:ext cx="10677236" cy="6232322"/>
+          </a:xfrm>
+          <a:prstGeom prst="rect">
+            <a:avLst/>
+          </a:prstGeom>
+        </p:spPr>
+      </p:pic>
+    </p:spTree>
+    <p:extLst>
+      <p:ext uri="{BB962C8B-B14F-4D97-AF65-F5344CB8AC3E}">
+        <p14:creationId xmlns:p14="http://schemas.microsoft.com/office/powerpoint/2010/main" val="3863838039"/>
+      </p:ext>
+    </p:extLst>
+  </p:cSld>
+  <p:clrMapOvr>
+    <a:masterClrMapping/>
+  </p:clrMapOvr>
+</p:sld>
+</file>
+
+<file path=ppt/slides/slide3.xml><?xml version="1.0" encoding="utf-8"?>
+<p:sld xmlns:a="http://schemas.openxmlformats.org/drawingml/2006/main" xmlns:r="http://schemas.openxmlformats.org/officeDocument/2006/relationships" xmlns:p="http://schemas.openxmlformats.org/presentationml/2006/main">
+  <p:cSld>
+    <p:spTree>
+      <p:nvGrpSpPr>
+        <p:cNvPr id="1" name="">
+          <a:extLst>
+            <a:ext uri="{FF2B5EF4-FFF2-40B4-BE49-F238E27FC236}">
               <a16:creationId xmlns:a16="http://schemas.microsoft.com/office/drawing/2014/main" id="{374F2F00-806B-AD52-C284-19E4A3CC8B3E}"/>
             </a:ext>
           </a:extLst>
@@ -4870,7 +5188,7 @@
 </p:sld>
 </file>
 
-<file path=ppt/slides/slide3.xml><?xml version="1.0" encoding="utf-8"?>
+<file path=ppt/slides/slide4.xml><?xml version="1.0" encoding="utf-8"?>
 <p:sld xmlns:a="http://schemas.openxmlformats.org/drawingml/2006/main" xmlns:r="http://schemas.openxmlformats.org/officeDocument/2006/relationships" xmlns:p="http://schemas.openxmlformats.org/presentationml/2006/main">
   <p:cSld>
     <p:spTree>
@@ -4995,7 +5313,7 @@
 </p:sld>
 </file>
 
-<file path=ppt/slides/slide4.xml><?xml version="1.0" encoding="utf-8"?>
+<file path=ppt/slides/slide5.xml><?xml version="1.0" encoding="utf-8"?>
 <p:sld xmlns:a="http://schemas.openxmlformats.org/drawingml/2006/main" xmlns:r="http://schemas.openxmlformats.org/officeDocument/2006/relationships" xmlns:p="http://schemas.openxmlformats.org/presentationml/2006/main">
   <p:cSld>
     <p:spTree>
@@ -5114,7 +5432,7 @@
 </p:sld>
 </file>
 
-<file path=ppt/slides/slide5.xml><?xml version="1.0" encoding="utf-8"?>
+<file path=ppt/slides/slide6.xml><?xml version="1.0" encoding="utf-8"?>
 <p:sld xmlns:a="http://schemas.openxmlformats.org/drawingml/2006/main" xmlns:r="http://schemas.openxmlformats.org/officeDocument/2006/relationships" xmlns:p="http://schemas.openxmlformats.org/presentationml/2006/main">
   <p:cSld>
     <p:spTree>
@@ -5251,7 +5569,7 @@
 </p:sld>
 </file>
 
-<file path=ppt/slides/slide6.xml><?xml version="1.0" encoding="utf-8"?>
+<file path=ppt/slides/slide7.xml><?xml version="1.0" encoding="utf-8"?>
 <p:sld xmlns:a="http://schemas.openxmlformats.org/drawingml/2006/main" xmlns:r="http://schemas.openxmlformats.org/officeDocument/2006/relationships" xmlns:p="http://schemas.openxmlformats.org/presentationml/2006/main">
   <p:cSld>
     <p:spTree>
@@ -5370,7 +5688,7 @@
 </p:sld>
 </file>
 
-<file path=ppt/slides/slide7.xml><?xml version="1.0" encoding="utf-8"?>
+<file path=ppt/slides/slide8.xml><?xml version="1.0" encoding="utf-8"?>
 <p:sld xmlns:a="http://schemas.openxmlformats.org/drawingml/2006/main" xmlns:r="http://schemas.openxmlformats.org/officeDocument/2006/relationships" xmlns:p="http://schemas.openxmlformats.org/presentationml/2006/main">
   <p:cSld>
     <p:spTree>
@@ -5496,7 +5814,7 @@
 </p:sld>
 </file>
 
-<file path=ppt/slides/slide8.xml><?xml version="1.0" encoding="utf-8"?>
+<file path=ppt/slides/slide9.xml><?xml version="1.0" encoding="utf-8"?>
 <p:sld xmlns:a="http://schemas.openxmlformats.org/drawingml/2006/main" xmlns:r="http://schemas.openxmlformats.org/officeDocument/2006/relationships" xmlns:p="http://schemas.openxmlformats.org/presentationml/2006/main">
   <p:cSld>
     <p:spTree>
@@ -5700,261 +6018,6 @@
     <p:extLst>
       <p:ext uri="{BB962C8B-B14F-4D97-AF65-F5344CB8AC3E}">
         <p14:creationId xmlns:p14="http://schemas.microsoft.com/office/powerpoint/2010/main" val="1145640986"/>
-      </p:ext>
-    </p:extLst>
-  </p:cSld>
-  <p:clrMapOvr>
-    <a:masterClrMapping/>
-  </p:clrMapOvr>
-</p:sld>
-</file>
-
-<file path=ppt/slides/slide9.xml><?xml version="1.0" encoding="utf-8"?>
-<p:sld xmlns:a="http://schemas.openxmlformats.org/drawingml/2006/main" xmlns:r="http://schemas.openxmlformats.org/officeDocument/2006/relationships" xmlns:p="http://schemas.openxmlformats.org/presentationml/2006/main">
-  <p:cSld>
-    <p:spTree>
-      <p:nvGrpSpPr>
-        <p:cNvPr id="1" name="">
-          <a:extLst>
-            <a:ext uri="{FF2B5EF4-FFF2-40B4-BE49-F238E27FC236}">
-              <a16:creationId xmlns:a16="http://schemas.microsoft.com/office/drawing/2014/main" id="{C9993877-C99C-9C5C-B92A-B6775E82B086}"/>
-            </a:ext>
-          </a:extLst>
-        </p:cNvPr>
-        <p:cNvGrpSpPr/>
-        <p:nvPr/>
-      </p:nvGrpSpPr>
-      <p:grpSpPr>
-        <a:xfrm>
-          <a:off x="0" y="0"/>
-          <a:ext cx="0" cy="0"/>
-          <a:chOff x="0" y="0"/>
-          <a:chExt cx="0" cy="0"/>
-        </a:xfrm>
-      </p:grpSpPr>
-      <p:sp>
-        <p:nvSpPr>
-          <p:cNvPr id="3" name="TextBox 2">
-            <a:extLst>
-              <a:ext uri="{FF2B5EF4-FFF2-40B4-BE49-F238E27FC236}">
-                <a16:creationId xmlns:a16="http://schemas.microsoft.com/office/drawing/2014/main" id="{66975D2F-2CDE-113B-A76A-B325FE701F97}"/>
-              </a:ext>
-            </a:extLst>
-          </p:cNvPr>
-          <p:cNvSpPr txBox="1"/>
-          <p:nvPr/>
-        </p:nvSpPr>
-        <p:spPr>
-          <a:xfrm>
-            <a:off x="0" y="0"/>
-            <a:ext cx="12192000" cy="335156"/>
-          </a:xfrm>
-          <a:prstGeom prst="rect">
-            <a:avLst/>
-          </a:prstGeom>
-          <a:noFill/>
-        </p:spPr>
-        <p:txBody>
-          <a:bodyPr wrap="square">
-            <a:spAutoFit/>
-          </a:bodyPr>
-          <a:lstStyle/>
-          <a:p>
-            <a:pPr>
-              <a:lnSpc>
-                <a:spcPct val="150000"/>
-              </a:lnSpc>
-              <a:buNone/>
-            </a:pPr>
-            <a:r>
-              <a:rPr lang="en-US" altLang="en-US" sz="1200" b="1">
-                <a:latin typeface="Arial" panose="020B0604020202020204" pitchFamily="34" charset="0"/>
-              </a:rPr>
-              <a:t>resources\views\vendor\dashboard\dashboard.blade.php</a:t>
-            </a:r>
-            <a:r>
-              <a:rPr lang="az-Latn-AZ" altLang="en-US" sz="1200" b="1">
-                <a:latin typeface="Arial" panose="020B0604020202020204" pitchFamily="34" charset="0"/>
-              </a:rPr>
-              <a:t> </a:t>
-            </a:r>
-            <a:r>
-              <a:rPr lang="az-Latn-AZ" altLang="en-US" sz="1200">
-                <a:latin typeface="Arial" panose="020B0604020202020204" pitchFamily="34" charset="0"/>
-              </a:rPr>
-              <a:t>və </a:t>
-            </a:r>
-            <a:r>
-              <a:rPr lang="en-US" altLang="en-US" sz="1200" b="1">
-                <a:latin typeface="Arial" panose="020B0604020202020204" pitchFamily="34" charset="0"/>
-              </a:rPr>
-              <a:t>resources\views\vendor\dashboard\profile.blade.php</a:t>
-            </a:r>
-            <a:r>
-              <a:rPr lang="az-Latn-AZ" altLang="en-US" sz="1200" b="1">
-                <a:latin typeface="Arial" panose="020B0604020202020204" pitchFamily="34" charset="0"/>
-              </a:rPr>
-              <a:t> </a:t>
-            </a:r>
-            <a:r>
-              <a:rPr lang="az-Latn-AZ" altLang="en-US" sz="1200">
-                <a:latin typeface="Arial" panose="020B0604020202020204" pitchFamily="34" charset="0"/>
-              </a:rPr>
-              <a:t>faylındakı yolları düzəldirik.</a:t>
-            </a:r>
-            <a:endParaRPr kumimoji="0" lang="en-US" altLang="en-US" sz="1200" b="0" i="0" u="none" strike="noStrike" cap="none" normalizeH="0" baseline="0">
-              <a:ln>
-                <a:noFill/>
-              </a:ln>
-              <a:solidFill>
-                <a:schemeClr val="tx1"/>
-              </a:solidFill>
-              <a:effectLst/>
-              <a:latin typeface="Arial" panose="020B0604020202020204" pitchFamily="34" charset="0"/>
-            </a:endParaRPr>
-          </a:p>
-        </p:txBody>
-      </p:sp>
-      <p:pic>
-        <p:nvPicPr>
-          <p:cNvPr id="4" name="Picture 3" descr="A screenshot of a computer program&#10;&#10;AI-generated content may be incorrect.">
-            <a:extLst>
-              <a:ext uri="{FF2B5EF4-FFF2-40B4-BE49-F238E27FC236}">
-                <a16:creationId xmlns:a16="http://schemas.microsoft.com/office/drawing/2014/main" id="{C209D8C4-EDC0-C271-4F83-3E1A830A5174}"/>
-              </a:ext>
-            </a:extLst>
-          </p:cNvPr>
-          <p:cNvPicPr>
-            <a:picLocks noChangeAspect="1"/>
-          </p:cNvPicPr>
-          <p:nvPr/>
-        </p:nvPicPr>
-        <p:blipFill>
-          <a:blip r:embed="rId2"/>
-          <a:stretch>
-            <a:fillRect/>
-          </a:stretch>
-        </p:blipFill>
-        <p:spPr>
-          <a:xfrm>
-            <a:off x="0" y="657923"/>
-            <a:ext cx="8020900" cy="2771078"/>
-          </a:xfrm>
-          <a:prstGeom prst="rect">
-            <a:avLst/>
-          </a:prstGeom>
-        </p:spPr>
-      </p:pic>
-      <p:pic>
-        <p:nvPicPr>
-          <p:cNvPr id="6" name="Picture 5" descr="A screenshot of a computer program&#10;&#10;AI-generated content may be incorrect.">
-            <a:extLst>
-              <a:ext uri="{FF2B5EF4-FFF2-40B4-BE49-F238E27FC236}">
-                <a16:creationId xmlns:a16="http://schemas.microsoft.com/office/drawing/2014/main" id="{2FC6F0B9-AC2E-1AC9-931E-4B1E73D8492B}"/>
-              </a:ext>
-            </a:extLst>
-          </p:cNvPr>
-          <p:cNvPicPr>
-            <a:picLocks noChangeAspect="1"/>
-          </p:cNvPicPr>
-          <p:nvPr/>
-        </p:nvPicPr>
-        <p:blipFill>
-          <a:blip r:embed="rId3"/>
-          <a:stretch>
-            <a:fillRect/>
-          </a:stretch>
-        </p:blipFill>
-        <p:spPr>
-          <a:xfrm>
-            <a:off x="0" y="3910304"/>
-            <a:ext cx="7989455" cy="2947696"/>
-          </a:xfrm>
-          <a:prstGeom prst="rect">
-            <a:avLst/>
-          </a:prstGeom>
-        </p:spPr>
-      </p:pic>
-      <p:sp>
-        <p:nvSpPr>
-          <p:cNvPr id="7" name="Arrow: Down 6">
-            <a:extLst>
-              <a:ext uri="{FF2B5EF4-FFF2-40B4-BE49-F238E27FC236}">
-                <a16:creationId xmlns:a16="http://schemas.microsoft.com/office/drawing/2014/main" id="{7D9A9959-AB55-4EDC-5FA1-B3F2EE056C06}"/>
-              </a:ext>
-            </a:extLst>
-          </p:cNvPr>
-          <p:cNvSpPr/>
-          <p:nvPr/>
-        </p:nvSpPr>
-        <p:spPr>
-          <a:xfrm>
-            <a:off x="3765686" y="3540343"/>
-            <a:ext cx="277091" cy="258618"/>
-          </a:xfrm>
-          <a:prstGeom prst="downArrow">
-            <a:avLst/>
-          </a:prstGeom>
-        </p:spPr>
-        <p:style>
-          <a:lnRef idx="2">
-            <a:schemeClr val="dk1">
-              <a:shade val="15000"/>
-            </a:schemeClr>
-          </a:lnRef>
-          <a:fillRef idx="1">
-            <a:schemeClr val="dk1"/>
-          </a:fillRef>
-          <a:effectRef idx="0">
-            <a:schemeClr val="dk1"/>
-          </a:effectRef>
-          <a:fontRef idx="minor">
-            <a:schemeClr val="lt1"/>
-          </a:fontRef>
-        </p:style>
-        <p:txBody>
-          <a:bodyPr rtlCol="0" anchor="ctr"/>
-          <a:lstStyle/>
-          <a:p>
-            <a:pPr algn="ctr"/>
-            <a:endParaRPr lang="en-US"/>
-          </a:p>
-        </p:txBody>
-      </p:sp>
-      <p:pic>
-        <p:nvPicPr>
-          <p:cNvPr id="9" name="Picture 8" descr="A screenshot of a computer&#10;&#10;AI-generated content may be incorrect.">
-            <a:extLst>
-              <a:ext uri="{FF2B5EF4-FFF2-40B4-BE49-F238E27FC236}">
-                <a16:creationId xmlns:a16="http://schemas.microsoft.com/office/drawing/2014/main" id="{270BD822-6123-409A-D2B5-0C82A3FE6CE8}"/>
-              </a:ext>
-            </a:extLst>
-          </p:cNvPr>
-          <p:cNvPicPr>
-            <a:picLocks noChangeAspect="1"/>
-          </p:cNvPicPr>
-          <p:nvPr/>
-        </p:nvPicPr>
-        <p:blipFill>
-          <a:blip r:embed="rId4"/>
-          <a:stretch>
-            <a:fillRect/>
-          </a:stretch>
-        </p:blipFill>
-        <p:spPr>
-          <a:xfrm>
-            <a:off x="9663717" y="657923"/>
-            <a:ext cx="2528283" cy="1226960"/>
-          </a:xfrm>
-          <a:prstGeom prst="rect">
-            <a:avLst/>
-          </a:prstGeom>
-        </p:spPr>
-      </p:pic>
-    </p:spTree>
-    <p:extLst>
-      <p:ext uri="{BB962C8B-B14F-4D97-AF65-F5344CB8AC3E}">
-        <p14:creationId xmlns:p14="http://schemas.microsoft.com/office/powerpoint/2010/main" val="1663773691"/>
       </p:ext>
     </p:extLst>
   </p:cSld>

</xml_diff>